<commit_message>
feat: complete 16-paper literature survey
</commit_message>
<xml_diff>
--- a/heart-disease-prediction/reports/Heart_Disease_Capstone_Presentation.pptx
+++ b/heart-disease-prediction/reports/Heart_Disease_Capstone_Presentation.pptx
@@ -20,6 +20,7 @@
     <p:sldId id="268" r:id="rId19"/>
     <p:sldId id="269" r:id="rId20"/>
     <p:sldId id="270" r:id="rId21"/>
+    <p:sldId id="271" r:id="rId22"/>
   </p:sldIdLst>
   <p:sldSz cx="12191695" cy="6858000" type="screen4x3"/>
   <p:notesSz cx="6858000" cy="9144000"/>
@@ -3270,7 +3271,7 @@
               </a:defRPr>
             </a:pPr>
             <a:r>
-              <a:t>Hyperparameter Tuning &amp; Optimization</a:t>
+              <a:t>Baseline Model Benchmark Results</a:t>
             </a:r>
           </a:p>
         </p:txBody>
@@ -3284,7 +3285,7 @@
         <p:spPr>
           <a:xfrm>
             <a:off x="731520" y="1645920"/>
-            <a:ext cx="10515600" cy="4572000"/>
+            <a:ext cx="5943600" cy="4572000"/>
           </a:xfrm>
           <a:prstGeom prst="rect">
             <a:avLst/>
@@ -3311,123 +3312,147 @@
                   <a:srgbClr val="1B365D"/>
                 </a:solidFill>
               </a:rPr>
-              <a:t>Tuned Models (5): </a:t>
-            </a:r>
-            <a:r>
-              <a:rPr sz="1500">
-                <a:solidFill>
-                  <a:srgbClr val="333333"/>
-                </a:solidFill>
-              </a:rPr>
-              <a:t>Logistic Regression (`GridSearchCV`), SVM (`GridSearchCV`), Random Forest (`RandomizedSearchCV`), XGBoost (`RandomizedSearchCV`), KNN (`GridSearchCV`).</a:t>
-            </a:r>
-          </a:p>
-          <a:p>
-            <a:pPr>
-              <a:lnSpc>
-                <a:spcPct val="115000"/>
-              </a:lnSpc>
-              <a:spcAft>
-                <a:spcPts val="1000"/>
-              </a:spcAft>
-            </a:pPr>
-            <a:r>
-              <a:rPr b="1" sz="1500">
-                <a:solidFill>
-                  <a:srgbClr val="1B365D"/>
-                </a:solidFill>
-              </a:rPr>
-              <a:t>Optimization Metric: </a:t>
-            </a:r>
-            <a:r>
-              <a:rPr sz="1500">
-                <a:solidFill>
-                  <a:srgbClr val="333333"/>
-                </a:solidFill>
-              </a:rPr>
-              <a:t>ROC-AUC calculated over 5-Fold Stratified Cross-Validation on `X_train_raw` (242 rows).</a:t>
-            </a:r>
-          </a:p>
-          <a:p>
-            <a:pPr>
-              <a:lnSpc>
-                <a:spcPct val="115000"/>
-              </a:lnSpc>
-              <a:spcAft>
-                <a:spcPts val="1000"/>
-              </a:spcAft>
-            </a:pPr>
-            <a:r>
-              <a:rPr b="1" sz="1500">
-                <a:solidFill>
-                  <a:srgbClr val="1B365D"/>
-                </a:solidFill>
-              </a:rPr>
-              <a:t>Random Forest Search Space: </a:t>
-            </a:r>
-            <a:r>
-              <a:rPr sz="1500">
-                <a:solidFill>
-                  <a:srgbClr val="333333"/>
-                </a:solidFill>
-              </a:rPr>
-              <a:t>`n_estimators` (100-500), `max_depth` (None, 5-20), `min_samples_split` (2-10), `min_samples_leaf` (1-4), `max_features` ('sqrt', 'log2'), `class_weight` ('balanced', 'balanced_subsample').</a:t>
-            </a:r>
-          </a:p>
-          <a:p>
-            <a:pPr>
-              <a:lnSpc>
-                <a:spcPct val="115000"/>
-              </a:lnSpc>
-              <a:spcAft>
-                <a:spcPts val="1000"/>
-              </a:spcAft>
-            </a:pPr>
-            <a:r>
-              <a:rPr b="1" sz="1500">
-                <a:solidFill>
-                  <a:srgbClr val="1B365D"/>
-                </a:solidFill>
-              </a:rPr>
-              <a:t>Frozen Configuration: </a:t>
-            </a:r>
-            <a:r>
-              <a:rPr sz="1500">
-                <a:solidFill>
-                  <a:srgbClr val="333333"/>
-                </a:solidFill>
-              </a:rPr>
-              <a:t>Winning parameters frozen in `best_parameters.json` BEFORE evaluating test set scores.</a:t>
-            </a:r>
-          </a:p>
-          <a:p>
-            <a:pPr>
-              <a:lnSpc>
-                <a:spcPct val="115000"/>
-              </a:lnSpc>
-              <a:spcAft>
-                <a:spcPts val="1000"/>
-              </a:spcAft>
-            </a:pPr>
-            <a:r>
-              <a:rPr b="1" sz="1500">
-                <a:solidFill>
-                  <a:srgbClr val="1B365D"/>
-                </a:solidFill>
-              </a:rPr>
-              <a:t>Tuned Results: </a:t>
-            </a:r>
-            <a:r>
-              <a:rPr sz="1500">
-                <a:solidFill>
-                  <a:srgbClr val="333333"/>
-                </a:solidFill>
-              </a:rPr>
-              <a:t>All 5 tuned models achieved CV ROC-AUC &gt; 0.899. Logistic Regression tuned CV ROC-AUC reached 0.9070.</a:t>
-            </a:r>
-          </a:p>
-        </p:txBody>
-      </p:sp>
+              <a:t>Logistic Regression: </a:t>
+            </a:r>
+            <a:r>
+              <a:rPr sz="1500">
+                <a:solidFill>
+                  <a:srgbClr val="333333"/>
+                </a:solidFill>
+              </a:rPr>
+              <a:t>CV ROC-AUC = 0.9025 | Test Acc = 0.8852 | Test Recall = 0.9286 | Test ROC-AUC = 0.9665</a:t>
+            </a:r>
+          </a:p>
+          <a:p>
+            <a:pPr>
+              <a:lnSpc>
+                <a:spcPct val="115000"/>
+              </a:lnSpc>
+              <a:spcAft>
+                <a:spcPts val="1000"/>
+              </a:spcAft>
+            </a:pPr>
+            <a:r>
+              <a:rPr b="1" sz="1500">
+                <a:solidFill>
+                  <a:srgbClr val="1B365D"/>
+                </a:solidFill>
+              </a:rPr>
+              <a:t>Support Vector Machine: </a:t>
+            </a:r>
+            <a:r>
+              <a:rPr sz="1500">
+                <a:solidFill>
+                  <a:srgbClr val="333333"/>
+                </a:solidFill>
+              </a:rPr>
+              <a:t>CV ROC-AUC = 0.8884 | Test Acc = 0.8852 | Test Recall = 0.9286 | Test ROC-AUC = 0.9643</a:t>
+            </a:r>
+          </a:p>
+          <a:p>
+            <a:pPr>
+              <a:lnSpc>
+                <a:spcPct val="115000"/>
+              </a:lnSpc>
+              <a:spcAft>
+                <a:spcPts val="1000"/>
+              </a:spcAft>
+            </a:pPr>
+            <a:r>
+              <a:rPr b="1" sz="1500">
+                <a:solidFill>
+                  <a:srgbClr val="1B365D"/>
+                </a:solidFill>
+              </a:rPr>
+              <a:t>Random Forest (Baseline): </a:t>
+            </a:r>
+            <a:r>
+              <a:rPr sz="1500">
+                <a:solidFill>
+                  <a:srgbClr val="333333"/>
+                </a:solidFill>
+              </a:rPr>
+              <a:t>CV ROC-AUC = 0.8968 | Test Acc = 0.8689 | Test Recall = 0.9286 | Test ROC-AUC = 0.9437</a:t>
+            </a:r>
+          </a:p>
+          <a:p>
+            <a:pPr>
+              <a:lnSpc>
+                <a:spcPct val="115000"/>
+              </a:lnSpc>
+              <a:spcAft>
+                <a:spcPts val="1000"/>
+              </a:spcAft>
+            </a:pPr>
+            <a:r>
+              <a:rPr b="1" sz="1500">
+                <a:solidFill>
+                  <a:srgbClr val="1B365D"/>
+                </a:solidFill>
+              </a:rPr>
+              <a:t>K-Nearest Neighbors: </a:t>
+            </a:r>
+            <a:r>
+              <a:rPr sz="1500">
+                <a:solidFill>
+                  <a:srgbClr val="333333"/>
+                </a:solidFill>
+              </a:rPr>
+              <a:t>CV ROC-AUC = 0.8712 | Test Acc = 0.8852 | Test Recall = 0.8929 | Test ROC-AUC = 0.9529</a:t>
+            </a:r>
+          </a:p>
+          <a:p>
+            <a:pPr>
+              <a:lnSpc>
+                <a:spcPct val="115000"/>
+              </a:lnSpc>
+              <a:spcAft>
+                <a:spcPts val="1000"/>
+              </a:spcAft>
+            </a:pPr>
+            <a:r>
+              <a:rPr b="1" sz="1500">
+                <a:solidFill>
+                  <a:srgbClr val="1B365D"/>
+                </a:solidFill>
+              </a:rPr>
+              <a:t>Gaussian Naive Bayes: </a:t>
+            </a:r>
+            <a:r>
+              <a:rPr sz="1500">
+                <a:solidFill>
+                  <a:srgbClr val="333333"/>
+                </a:solidFill>
+              </a:rPr>
+              <a:t>CV ROC-AUC = 0.8773 | Test Acc = 0.7213 | Test Recall = 0.8929 | Test ROC-AUC = 0.8268</a:t>
+            </a:r>
+          </a:p>
+        </p:txBody>
+      </p:sp>
+      <p:pic>
+        <p:nvPicPr>
+          <p:cNvPr id="5" name="Picture 4" descr="baseline_model_comparison.png"/>
+          <p:cNvPicPr>
+            <a:picLocks noChangeAspect="1"/>
+          </p:cNvPicPr>
+          <p:nvPr/>
+        </p:nvPicPr>
+        <p:blipFill>
+          <a:blip r:embed="rId2"/>
+          <a:stretch>
+            <a:fillRect/>
+          </a:stretch>
+        </p:blipFill>
+        <p:spPr>
+          <a:xfrm>
+            <a:off x="6858000" y="1645920"/>
+            <a:ext cx="4754880" cy="2377440"/>
+          </a:xfrm>
+          <a:prstGeom prst="rect">
+            <a:avLst/>
+          </a:prstGeom>
+        </p:spPr>
+      </p:pic>
     </p:spTree>
   </p:cSld>
   <p:clrMapOvr>
@@ -3511,7 +3536,7 @@
               </a:defRPr>
             </a:pPr>
             <a:r>
-              <a:t>Final Model Selection Rationale</a:t>
+              <a:t>Hyperparameter Tuning &amp; Optimization</a:t>
             </a:r>
           </a:p>
         </p:txBody>
@@ -3552,145 +3577,119 @@
                   <a:srgbClr val="1B365D"/>
                 </a:solidFill>
               </a:rPr>
-              <a:t>Selected Final Model: </a:t>
-            </a:r>
-            <a:r>
-              <a:rPr sz="1500">
-                <a:solidFill>
-                  <a:srgbClr val="333333"/>
-                </a:solidFill>
-              </a:rPr>
-              <a:t>**Tuned Random Forest** (`RandomForestClassifier`)</a:t>
-            </a:r>
-          </a:p>
-          <a:p>
-            <a:pPr>
-              <a:lnSpc>
-                <a:spcPct val="115000"/>
-              </a:lnSpc>
-              <a:spcAft>
-                <a:spcPts val="1000"/>
-              </a:spcAft>
-            </a:pPr>
-            <a:r>
-              <a:rPr b="1" sz="1500">
-                <a:solidFill>
-                  <a:srgbClr val="1B365D"/>
-                </a:solidFill>
-              </a:rPr>
-              <a:t>Highest Test Accuracy: </a:t>
-            </a:r>
-            <a:r>
-              <a:rPr sz="1500">
-                <a:solidFill>
-                  <a:srgbClr val="333333"/>
-                </a:solidFill>
-              </a:rPr>
-              <a:t>**0.9016** (55 / 61 correct) — highest accuracy among all 12 candidate models.</a:t>
-            </a:r>
-          </a:p>
-          <a:p>
-            <a:pPr>
-              <a:lnSpc>
-                <a:spcPct val="115000"/>
-              </a:lnSpc>
-              <a:spcAft>
-                <a:spcPts val="1000"/>
-              </a:spcAft>
-            </a:pPr>
-            <a:r>
-              <a:rPr b="1" sz="1500">
-                <a:solidFill>
-                  <a:srgbClr val="1B365D"/>
-                </a:solidFill>
-              </a:rPr>
-              <a:t>Highest Test Recall (Sensitivity): </a:t>
-            </a:r>
-            <a:r>
-              <a:rPr sz="1500">
-                <a:solidFill>
-                  <a:srgbClr val="333333"/>
-                </a:solidFill>
-              </a:rPr>
-              <a:t>**0.9643** (27 / 28 actual disease cases detected) — crucial for medical screening.</a:t>
-            </a:r>
-          </a:p>
-          <a:p>
-            <a:pPr>
-              <a:lnSpc>
-                <a:spcPct val="115000"/>
-              </a:lnSpc>
-              <a:spcAft>
-                <a:spcPts val="1000"/>
-              </a:spcAft>
-            </a:pPr>
-            <a:r>
-              <a:rPr b="1" sz="1500">
-                <a:solidFill>
-                  <a:srgbClr val="1B365D"/>
-                </a:solidFill>
-              </a:rPr>
-              <a:t>Lowest False Negatives: </a:t>
-            </a:r>
-            <a:r>
-              <a:rPr sz="1500">
-                <a:solidFill>
-                  <a:srgbClr val="333333"/>
-                </a:solidFill>
-              </a:rPr>
-              <a:t>**FN = 1** (Only 1 disease-positive case misclassified as healthy on 61-row test set).</a:t>
-            </a:r>
-          </a:p>
-          <a:p>
-            <a:pPr>
-              <a:lnSpc>
-                <a:spcPct val="115000"/>
-              </a:lnSpc>
-              <a:spcAft>
-                <a:spcPts val="1000"/>
-              </a:spcAft>
-            </a:pPr>
-            <a:r>
-              <a:rPr b="1" sz="1500">
-                <a:solidFill>
-                  <a:srgbClr val="1B365D"/>
-                </a:solidFill>
-              </a:rPr>
-              <a:t>Highest Test F1-Score: </a:t>
-            </a:r>
-            <a:r>
-              <a:rPr sz="1500">
-                <a:solidFill>
-                  <a:srgbClr val="333333"/>
-                </a:solidFill>
-              </a:rPr>
-              <a:t>**0.9000** — optimal balance between Precision (0.8438) and Recall (0.9643).</a:t>
-            </a:r>
-          </a:p>
-          <a:p>
-            <a:pPr>
-              <a:lnSpc>
-                <a:spcPct val="115000"/>
-              </a:lnSpc>
-              <a:spcAft>
-                <a:spcPts val="1000"/>
-              </a:spcAft>
-            </a:pPr>
-            <a:r>
-              <a:rPr b="1" sz="1500">
-                <a:solidFill>
-                  <a:srgbClr val="1B365D"/>
-                </a:solidFill>
-              </a:rPr>
-              <a:t>Strong CV Stability: </a:t>
-            </a:r>
-            <a:r>
-              <a:rPr sz="1500">
-                <a:solidFill>
-                  <a:srgbClr val="333333"/>
-                </a:solidFill>
-              </a:rPr>
-              <a:t>CV ROC-AUC = **0.9041 ± 0.0282** | CV Recall = **0.8008**.</a:t>
+              <a:t>Tuned Models (5): </a:t>
+            </a:r>
+            <a:r>
+              <a:rPr sz="1500">
+                <a:solidFill>
+                  <a:srgbClr val="333333"/>
+                </a:solidFill>
+              </a:rPr>
+              <a:t>Logistic Regression (`GridSearchCV`), SVM (`GridSearchCV`), Random Forest (`RandomizedSearchCV`), XGBoost (`RandomizedSearchCV`), KNN (`GridSearchCV`).</a:t>
+            </a:r>
+          </a:p>
+          <a:p>
+            <a:pPr>
+              <a:lnSpc>
+                <a:spcPct val="115000"/>
+              </a:lnSpc>
+              <a:spcAft>
+                <a:spcPts val="1000"/>
+              </a:spcAft>
+            </a:pPr>
+            <a:r>
+              <a:rPr b="1" sz="1500">
+                <a:solidFill>
+                  <a:srgbClr val="1B365D"/>
+                </a:solidFill>
+              </a:rPr>
+              <a:t>Optimization Metric: </a:t>
+            </a:r>
+            <a:r>
+              <a:rPr sz="1500">
+                <a:solidFill>
+                  <a:srgbClr val="333333"/>
+                </a:solidFill>
+              </a:rPr>
+              <a:t>ROC-AUC calculated over 5-Fold Stratified Cross-Validation on `X_train_raw` (242 rows).</a:t>
+            </a:r>
+          </a:p>
+          <a:p>
+            <a:pPr>
+              <a:lnSpc>
+                <a:spcPct val="115000"/>
+              </a:lnSpc>
+              <a:spcAft>
+                <a:spcPts val="1000"/>
+              </a:spcAft>
+            </a:pPr>
+            <a:r>
+              <a:rPr b="1" sz="1500">
+                <a:solidFill>
+                  <a:srgbClr val="1B365D"/>
+                </a:solidFill>
+              </a:rPr>
+              <a:t>Random Forest Search Space: </a:t>
+            </a:r>
+            <a:r>
+              <a:rPr sz="1500">
+                <a:solidFill>
+                  <a:srgbClr val="333333"/>
+                </a:solidFill>
+              </a:rPr>
+              <a:t>`n_estimators` (100-500), `max_depth` (None, 5-20), `min_samples_split` (2-10), `min_samples_leaf` (1-4), `max_features` ('sqrt', 'log2'), `class_weight` ('balanced', 'balanced_subsample').</a:t>
+            </a:r>
+          </a:p>
+          <a:p>
+            <a:pPr>
+              <a:lnSpc>
+                <a:spcPct val="115000"/>
+              </a:lnSpc>
+              <a:spcAft>
+                <a:spcPts val="1000"/>
+              </a:spcAft>
+            </a:pPr>
+            <a:r>
+              <a:rPr b="1" sz="1500">
+                <a:solidFill>
+                  <a:srgbClr val="1B365D"/>
+                </a:solidFill>
+              </a:rPr>
+              <a:t>Frozen Configuration: </a:t>
+            </a:r>
+            <a:r>
+              <a:rPr sz="1500">
+                <a:solidFill>
+                  <a:srgbClr val="333333"/>
+                </a:solidFill>
+              </a:rPr>
+              <a:t>Winning parameters frozen in `best_parameters.json` BEFORE evaluating test set scores.</a:t>
+            </a:r>
+          </a:p>
+          <a:p>
+            <a:pPr>
+              <a:lnSpc>
+                <a:spcPct val="115000"/>
+              </a:lnSpc>
+              <a:spcAft>
+                <a:spcPts val="1000"/>
+              </a:spcAft>
+            </a:pPr>
+            <a:r>
+              <a:rPr b="1" sz="1500">
+                <a:solidFill>
+                  <a:srgbClr val="1B365D"/>
+                </a:solidFill>
+              </a:rPr>
+              <a:t>Tuned Results: </a:t>
+            </a:r>
+            <a:r>
+              <a:rPr sz="1500">
+                <a:solidFill>
+                  <a:srgbClr val="333333"/>
+                </a:solidFill>
+              </a:rPr>
+              <a:t>All 5 tuned models achieved CV ROC-AUC &gt; 0.899. Logistic Regression tuned CV ROC-AUC reached 0.9070.</a:t>
             </a:r>
           </a:p>
         </p:txBody>
@@ -3704,6 +3703,273 @@
 </file>
 
 <file path=ppt/slides/slide12.xml><?xml version="1.0" encoding="utf-8"?>
+<p:sld xmlns:a="http://schemas.openxmlformats.org/drawingml/2006/main" xmlns:p="http://schemas.openxmlformats.org/presentationml/2006/main" xmlns:r="http://schemas.openxmlformats.org/officeDocument/2006/relationships">
+  <p:cSld>
+    <p:spTree>
+      <p:nvGrpSpPr>
+        <p:cNvPr id="1" name=""/>
+        <p:cNvGrpSpPr/>
+        <p:nvPr/>
+      </p:nvGrpSpPr>
+      <p:grpSpPr/>
+      <p:sp>
+        <p:nvSpPr>
+          <p:cNvPr id="2" name="TextBox 1"/>
+          <p:cNvSpPr txBox="1"/>
+          <p:nvPr/>
+        </p:nvSpPr>
+        <p:spPr>
+          <a:xfrm>
+            <a:off x="731520" y="365760"/>
+            <a:ext cx="10058400" cy="365760"/>
+          </a:xfrm>
+          <a:prstGeom prst="rect">
+            <a:avLst/>
+          </a:prstGeom>
+          <a:noFill/>
+        </p:spPr>
+        <p:txBody>
+          <a:bodyPr wrap="none">
+            <a:spAutoFit/>
+          </a:bodyPr>
+          <a:lstStyle/>
+          <a:p>
+            <a:pPr>
+              <a:defRPr sz="1000" b="1">
+                <a:solidFill>
+                  <a:srgbClr val="4B6B94"/>
+                </a:solidFill>
+              </a:defRPr>
+            </a:pPr>
+            <a:r>
+              <a:t>CAPSTONE PRESENTATION</a:t>
+            </a:r>
+          </a:p>
+        </p:txBody>
+      </p:sp>
+      <p:sp>
+        <p:nvSpPr>
+          <p:cNvPr id="3" name="TextBox 2"/>
+          <p:cNvSpPr txBox="1"/>
+          <p:nvPr/>
+        </p:nvSpPr>
+        <p:spPr>
+          <a:xfrm>
+            <a:off x="731520" y="640080"/>
+            <a:ext cx="10515600" cy="731520"/>
+          </a:xfrm>
+          <a:prstGeom prst="rect">
+            <a:avLst/>
+          </a:prstGeom>
+          <a:noFill/>
+        </p:spPr>
+        <p:txBody>
+          <a:bodyPr wrap="none">
+            <a:spAutoFit/>
+          </a:bodyPr>
+          <a:lstStyle/>
+          <a:p>
+            <a:pPr>
+              <a:defRPr sz="2400" b="1">
+                <a:solidFill>
+                  <a:srgbClr val="1B365D"/>
+                </a:solidFill>
+              </a:defRPr>
+            </a:pPr>
+            <a:r>
+              <a:t>Final Model Selection Rationale</a:t>
+            </a:r>
+          </a:p>
+        </p:txBody>
+      </p:sp>
+      <p:sp>
+        <p:nvSpPr>
+          <p:cNvPr id="4" name="TextBox 3"/>
+          <p:cNvSpPr txBox="1"/>
+          <p:nvPr/>
+        </p:nvSpPr>
+        <p:spPr>
+          <a:xfrm>
+            <a:off x="731520" y="1645920"/>
+            <a:ext cx="10515600" cy="4572000"/>
+          </a:xfrm>
+          <a:prstGeom prst="rect">
+            <a:avLst/>
+          </a:prstGeom>
+          <a:noFill/>
+        </p:spPr>
+        <p:txBody>
+          <a:bodyPr wrap="square">
+            <a:spAutoFit/>
+          </a:bodyPr>
+          <a:lstStyle/>
+          <a:p>
+            <a:pPr>
+              <a:lnSpc>
+                <a:spcPct val="115000"/>
+              </a:lnSpc>
+              <a:spcAft>
+                <a:spcPts val="1000"/>
+              </a:spcAft>
+            </a:pPr>
+            <a:r>
+              <a:rPr b="1" sz="1500">
+                <a:solidFill>
+                  <a:srgbClr val="1B365D"/>
+                </a:solidFill>
+              </a:rPr>
+              <a:t>Selected Final Model: </a:t>
+            </a:r>
+            <a:r>
+              <a:rPr sz="1500">
+                <a:solidFill>
+                  <a:srgbClr val="333333"/>
+                </a:solidFill>
+              </a:rPr>
+              <a:t>**Tuned Random Forest** (`RandomForestClassifier`)</a:t>
+            </a:r>
+          </a:p>
+          <a:p>
+            <a:pPr>
+              <a:lnSpc>
+                <a:spcPct val="115000"/>
+              </a:lnSpc>
+              <a:spcAft>
+                <a:spcPts val="1000"/>
+              </a:spcAft>
+            </a:pPr>
+            <a:r>
+              <a:rPr b="1" sz="1500">
+                <a:solidFill>
+                  <a:srgbClr val="1B365D"/>
+                </a:solidFill>
+              </a:rPr>
+              <a:t>Highest Test Accuracy: </a:t>
+            </a:r>
+            <a:r>
+              <a:rPr sz="1500">
+                <a:solidFill>
+                  <a:srgbClr val="333333"/>
+                </a:solidFill>
+              </a:rPr>
+              <a:t>**0.9016** (55 / 61 correct) — highest accuracy among all 12 candidate models.</a:t>
+            </a:r>
+          </a:p>
+          <a:p>
+            <a:pPr>
+              <a:lnSpc>
+                <a:spcPct val="115000"/>
+              </a:lnSpc>
+              <a:spcAft>
+                <a:spcPts val="1000"/>
+              </a:spcAft>
+            </a:pPr>
+            <a:r>
+              <a:rPr b="1" sz="1500">
+                <a:solidFill>
+                  <a:srgbClr val="1B365D"/>
+                </a:solidFill>
+              </a:rPr>
+              <a:t>Highest Test Recall (Sensitivity): </a:t>
+            </a:r>
+            <a:r>
+              <a:rPr sz="1500">
+                <a:solidFill>
+                  <a:srgbClr val="333333"/>
+                </a:solidFill>
+              </a:rPr>
+              <a:t>**0.9643** (27 / 28 actual disease cases detected) — crucial for medical screening.</a:t>
+            </a:r>
+          </a:p>
+          <a:p>
+            <a:pPr>
+              <a:lnSpc>
+                <a:spcPct val="115000"/>
+              </a:lnSpc>
+              <a:spcAft>
+                <a:spcPts val="1000"/>
+              </a:spcAft>
+            </a:pPr>
+            <a:r>
+              <a:rPr b="1" sz="1500">
+                <a:solidFill>
+                  <a:srgbClr val="1B365D"/>
+                </a:solidFill>
+              </a:rPr>
+              <a:t>Lowest False Negatives: </a:t>
+            </a:r>
+            <a:r>
+              <a:rPr sz="1500">
+                <a:solidFill>
+                  <a:srgbClr val="333333"/>
+                </a:solidFill>
+              </a:rPr>
+              <a:t>**FN = 1** (Only 1 disease-positive case misclassified as healthy on 61-row test set).</a:t>
+            </a:r>
+          </a:p>
+          <a:p>
+            <a:pPr>
+              <a:lnSpc>
+                <a:spcPct val="115000"/>
+              </a:lnSpc>
+              <a:spcAft>
+                <a:spcPts val="1000"/>
+              </a:spcAft>
+            </a:pPr>
+            <a:r>
+              <a:rPr b="1" sz="1500">
+                <a:solidFill>
+                  <a:srgbClr val="1B365D"/>
+                </a:solidFill>
+              </a:rPr>
+              <a:t>Highest Test F1-Score: </a:t>
+            </a:r>
+            <a:r>
+              <a:rPr sz="1500">
+                <a:solidFill>
+                  <a:srgbClr val="333333"/>
+                </a:solidFill>
+              </a:rPr>
+              <a:t>**0.9000** — optimal balance between Precision (0.8438) and Recall (0.9643).</a:t>
+            </a:r>
+          </a:p>
+          <a:p>
+            <a:pPr>
+              <a:lnSpc>
+                <a:spcPct val="115000"/>
+              </a:lnSpc>
+              <a:spcAft>
+                <a:spcPts val="1000"/>
+              </a:spcAft>
+            </a:pPr>
+            <a:r>
+              <a:rPr b="1" sz="1500">
+                <a:solidFill>
+                  <a:srgbClr val="1B365D"/>
+                </a:solidFill>
+              </a:rPr>
+              <a:t>Strong CV Stability: </a:t>
+            </a:r>
+            <a:r>
+              <a:rPr sz="1500">
+                <a:solidFill>
+                  <a:srgbClr val="333333"/>
+                </a:solidFill>
+              </a:rPr>
+              <a:t>CV ROC-AUC = **0.9041 ± 0.0282** | CV Recall = **0.8008**.</a:t>
+            </a:r>
+          </a:p>
+        </p:txBody>
+      </p:sp>
+    </p:spTree>
+  </p:cSld>
+  <p:clrMapOvr>
+    <a:masterClrMapping/>
+  </p:clrMapOvr>
+</p:sld>
+</file>
+
+<file path=ppt/slides/slide13.xml><?xml version="1.0" encoding="utf-8"?>
 <p:sld xmlns:a="http://schemas.openxmlformats.org/drawingml/2006/main" xmlns:p="http://schemas.openxmlformats.org/presentationml/2006/main" xmlns:r="http://schemas.openxmlformats.org/officeDocument/2006/relationships">
   <p:cSld>
     <p:spTree>
@@ -3994,7 +4260,7 @@
 </p:sld>
 </file>
 
-<file path=ppt/slides/slide13.xml><?xml version="1.0" encoding="utf-8"?>
+<file path=ppt/slides/slide14.xml><?xml version="1.0" encoding="utf-8"?>
 <p:sld xmlns:a="http://schemas.openxmlformats.org/drawingml/2006/main" xmlns:p="http://schemas.openxmlformats.org/presentationml/2006/main" xmlns:r="http://schemas.openxmlformats.org/officeDocument/2006/relationships">
   <p:cSld>
     <p:spTree>
@@ -4285,7 +4551,7 @@
 </p:sld>
 </file>
 
-<file path=ppt/slides/slide14.xml><?xml version="1.0" encoding="utf-8"?>
+<file path=ppt/slides/slide15.xml><?xml version="1.0" encoding="utf-8"?>
 <p:sld xmlns:a="http://schemas.openxmlformats.org/drawingml/2006/main" xmlns:p="http://schemas.openxmlformats.org/presentationml/2006/main" xmlns:r="http://schemas.openxmlformats.org/officeDocument/2006/relationships">
   <p:cSld>
     <p:spTree>
@@ -4552,7 +4818,7 @@
 </p:sld>
 </file>
 
-<file path=ppt/slides/slide15.xml><?xml version="1.0" encoding="utf-8"?>
+<file path=ppt/slides/slide16.xml><?xml version="1.0" encoding="utf-8"?>
 <p:sld xmlns:a="http://schemas.openxmlformats.org/drawingml/2006/main" xmlns:p="http://schemas.openxmlformats.org/presentationml/2006/main" xmlns:r="http://schemas.openxmlformats.org/officeDocument/2006/relationships">
   <p:cSld>
     <p:spTree>
@@ -5074,7 +5340,7 @@
               </a:defRPr>
             </a:pPr>
             <a:r>
-              <a:t>CAPSTONE PRESENTATION</a:t>
+              <a:t>PROJECT OVERVIEW</a:t>
             </a:r>
           </a:p>
         </p:txBody>
@@ -5109,7 +5375,7 @@
               </a:defRPr>
             </a:pPr>
             <a:r>
-              <a:t>Project Objectives</a:t>
+              <a:t>Project Objectives &amp; Scope</a:t>
             </a:r>
           </a:p>
         </p:txBody>
@@ -5150,145 +5416,145 @@
                   <a:srgbClr val="1B365D"/>
                 </a:solidFill>
               </a:rPr>
-              <a:t>1. Dataset Integration: </a:t>
-            </a:r>
-            <a:r>
-              <a:rPr sz="1500">
-                <a:solidFill>
-                  <a:srgbClr val="333333"/>
-                </a:solidFill>
-              </a:rPr>
-              <a:t>Acquire, inspect, and validate the UCI Cleveland Heart Disease dataset (303 rows, 13 predictors).</a:t>
-            </a:r>
-          </a:p>
-          <a:p>
-            <a:pPr>
-              <a:lnSpc>
-                <a:spcPct val="115000"/>
-              </a:lnSpc>
-              <a:spcAft>
-                <a:spcPts val="1000"/>
-              </a:spcAft>
-            </a:pPr>
-            <a:r>
-              <a:rPr b="1" sz="1500">
-                <a:solidFill>
-                  <a:srgbClr val="1B365D"/>
-                </a:solidFill>
-              </a:rPr>
-              <a:t>2. Data Preprocessing: </a:t>
-            </a:r>
-            <a:r>
-              <a:rPr sz="1500">
-                <a:solidFill>
-                  <a:srgbClr val="333333"/>
-                </a:solidFill>
-              </a:rPr>
-              <a:t>Build a leakage-safe preprocessing pipeline combining median/mode imputation, StandardScaler, and OneHotEncoder.</a:t>
-            </a:r>
-          </a:p>
-          <a:p>
-            <a:pPr>
-              <a:lnSpc>
-                <a:spcPct val="115000"/>
-              </a:lnSpc>
-              <a:spcAft>
-                <a:spcPts val="1000"/>
-              </a:spcAft>
-            </a:pPr>
-            <a:r>
-              <a:rPr b="1" sz="1500">
-                <a:solidFill>
-                  <a:srgbClr val="1B365D"/>
-                </a:solidFill>
-              </a:rPr>
-              <a:t>3. Exploratory Analysis: </a:t>
-            </a:r>
-            <a:r>
-              <a:rPr sz="1500">
-                <a:solidFill>
-                  <a:srgbClr val="333333"/>
-                </a:solidFill>
-              </a:rPr>
-              <a:t>Conduct thorough EDA producing 21 high-resolution plots to analyze feature distributions and correlations.</a:t>
-            </a:r>
-          </a:p>
-          <a:p>
-            <a:pPr>
-              <a:lnSpc>
-                <a:spcPct val="115000"/>
-              </a:lnSpc>
-              <a:spcAft>
-                <a:spcPts val="1000"/>
-              </a:spcAft>
-            </a:pPr>
-            <a:r>
-              <a:rPr b="1" sz="1500">
-                <a:solidFill>
-                  <a:srgbClr val="1B365D"/>
-                </a:solidFill>
-              </a:rPr>
-              <a:t>4. Baseline Benchmarking: </a:t>
-            </a:r>
-            <a:r>
-              <a:rPr sz="1500">
-                <a:solidFill>
-                  <a:srgbClr val="333333"/>
-                </a:solidFill>
-              </a:rPr>
-              <a:t>Evaluate 7 machine learning algorithms using 5-Fold Stratified Cross-Validation strictly on training data.</a:t>
-            </a:r>
-          </a:p>
-          <a:p>
-            <a:pPr>
-              <a:lnSpc>
-                <a:spcPct val="115000"/>
-              </a:lnSpc>
-              <a:spcAft>
-                <a:spcPts val="1000"/>
-              </a:spcAft>
-            </a:pPr>
-            <a:r>
-              <a:rPr b="1" sz="1500">
-                <a:solidFill>
-                  <a:srgbClr val="1B365D"/>
-                </a:solidFill>
-              </a:rPr>
-              <a:t>5. Hyperparameter Tuning: </a:t>
-            </a:r>
-            <a:r>
-              <a:rPr sz="1500">
-                <a:solidFill>
-                  <a:srgbClr val="333333"/>
-                </a:solidFill>
-              </a:rPr>
-              <a:t>Optimize candidate classifiers via Grid/Randomized search while keeping held-out test data isolated.</a:t>
-            </a:r>
-          </a:p>
-          <a:p>
-            <a:pPr>
-              <a:lnSpc>
-                <a:spcPct val="115000"/>
-              </a:lnSpc>
-              <a:spcAft>
-                <a:spcPts val="1000"/>
-              </a:spcAft>
-            </a:pPr>
-            <a:r>
-              <a:rPr b="1" sz="1500">
-                <a:solidFill>
-                  <a:srgbClr val="1B365D"/>
-                </a:solidFill>
-              </a:rPr>
-              <a:t>6. Model Freezing &amp; Web App: </a:t>
-            </a:r>
-            <a:r>
-              <a:rPr sz="1500">
-                <a:solidFill>
-                  <a:srgbClr val="333333"/>
-                </a:solidFill>
-              </a:rPr>
-              <a:t>Freeze the winning pipeline (Tuned Random Forest) and deploy via an interactive Streamlit web application (`app.py`).</a:t>
+              <a:t>End-to-End Pipeline: </a:t>
+            </a:r>
+            <a:r>
+              <a:rPr sz="1500">
+                <a:solidFill>
+                  <a:srgbClr val="333333"/>
+                </a:solidFill>
+              </a:rPr>
+              <a:t>Build a leak-free Machine Learning and Deep Learning prediction pipeline.</a:t>
+            </a:r>
+          </a:p>
+          <a:p>
+            <a:pPr>
+              <a:lnSpc>
+                <a:spcPct val="115000"/>
+              </a:lnSpc>
+              <a:spcAft>
+                <a:spcPts val="1000"/>
+              </a:spcAft>
+            </a:pPr>
+            <a:r>
+              <a:rPr b="1" sz="1500">
+                <a:solidFill>
+                  <a:srgbClr val="1B365D"/>
+                </a:solidFill>
+              </a:rPr>
+              <a:t>UCI Cleveland Dataset: </a:t>
+            </a:r>
+            <a:r>
+              <a:rPr sz="1500">
+                <a:solidFill>
+                  <a:srgbClr val="333333"/>
+                </a:solidFill>
+              </a:rPr>
+              <a:t>Utilize 303 patient clinical observations (13 predictors, binary target).</a:t>
+            </a:r>
+          </a:p>
+          <a:p>
+            <a:pPr>
+              <a:lnSpc>
+                <a:spcPct val="115000"/>
+              </a:lnSpc>
+              <a:spcAft>
+                <a:spcPts val="1000"/>
+              </a:spcAft>
+            </a:pPr>
+            <a:r>
+              <a:rPr b="1" sz="1500">
+                <a:solidFill>
+                  <a:srgbClr val="1B365D"/>
+                </a:solidFill>
+              </a:rPr>
+              <a:t>Multi-Model Benchmarking: </a:t>
+            </a:r>
+            <a:r>
+              <a:rPr sz="1500">
+                <a:solidFill>
+                  <a:srgbClr val="333333"/>
+                </a:solidFill>
+              </a:rPr>
+              <a:t>Train and evaluate 7 baseline ML models and candidate ANN DL architectures.</a:t>
+            </a:r>
+          </a:p>
+          <a:p>
+            <a:pPr>
+              <a:lnSpc>
+                <a:spcPct val="115000"/>
+              </a:lnSpc>
+              <a:spcAft>
+                <a:spcPts val="1000"/>
+              </a:spcAft>
+            </a:pPr>
+            <a:r>
+              <a:rPr b="1" sz="1500">
+                <a:solidFill>
+                  <a:srgbClr val="1B365D"/>
+                </a:solidFill>
+              </a:rPr>
+              <a:t>Hyperparameter Tuning: </a:t>
+            </a:r>
+            <a:r>
+              <a:rPr sz="1500">
+                <a:solidFill>
+                  <a:srgbClr val="333333"/>
+                </a:solidFill>
+              </a:rPr>
+              <a:t>Perform 5-fold cross-validation grid search to optimize model hyperparameters.</a:t>
+            </a:r>
+          </a:p>
+          <a:p>
+            <a:pPr>
+              <a:lnSpc>
+                <a:spcPct val="115000"/>
+              </a:lnSpc>
+              <a:spcAft>
+                <a:spcPts val="1000"/>
+              </a:spcAft>
+            </a:pPr>
+            <a:r>
+              <a:rPr b="1" sz="1500">
+                <a:solidFill>
+                  <a:srgbClr val="1B365D"/>
+                </a:solidFill>
+              </a:rPr>
+              <a:t>Literature Survey Integration: </a:t>
+            </a:r>
+            <a:r>
+              <a:rPr sz="1500">
+                <a:solidFill>
+                  <a:srgbClr val="333333"/>
+                </a:solidFill>
+              </a:rPr>
+              <a:t>Benchmark methodology against 16 verified academic research papers.</a:t>
+            </a:r>
+          </a:p>
+          <a:p>
+            <a:pPr>
+              <a:lnSpc>
+                <a:spcPct val="115000"/>
+              </a:lnSpc>
+              <a:spcAft>
+                <a:spcPts val="1000"/>
+              </a:spcAft>
+            </a:pPr>
+            <a:r>
+              <a:rPr b="1" sz="1500">
+                <a:solidFill>
+                  <a:srgbClr val="1B365D"/>
+                </a:solidFill>
+              </a:rPr>
+              <a:t>Web Application Deployment: </a:t>
+            </a:r>
+            <a:r>
+              <a:rPr sz="1500">
+                <a:solidFill>
+                  <a:srgbClr val="333333"/>
+                </a:solidFill>
+              </a:rPr>
+              <a:t>Deploy interactive Streamlit application (app.py) for real-time risk assessment.</a:t>
             </a:r>
           </a:p>
         </p:txBody>
@@ -5311,229 +5577,6 @@
         <p:nvPr/>
       </p:nvGrpSpPr>
       <p:grpSpPr/>
-      <p:sp>
-        <p:nvSpPr>
-          <p:cNvPr id="2" name="TextBox 1"/>
-          <p:cNvSpPr txBox="1"/>
-          <p:nvPr/>
-        </p:nvSpPr>
-        <p:spPr>
-          <a:xfrm>
-            <a:off x="731520" y="365760"/>
-            <a:ext cx="10058400" cy="365760"/>
-          </a:xfrm>
-          <a:prstGeom prst="rect">
-            <a:avLst/>
-          </a:prstGeom>
-          <a:noFill/>
-        </p:spPr>
-        <p:txBody>
-          <a:bodyPr wrap="none">
-            <a:spAutoFit/>
-          </a:bodyPr>
-          <a:lstStyle/>
-          <a:p>
-            <a:pPr>
-              <a:defRPr sz="1000" b="1">
-                <a:solidFill>
-                  <a:srgbClr val="4B6B94"/>
-                </a:solidFill>
-              </a:defRPr>
-            </a:pPr>
-            <a:r>
-              <a:t>CAPSTONE PRESENTATION</a:t>
-            </a:r>
-          </a:p>
-        </p:txBody>
-      </p:sp>
-      <p:sp>
-        <p:nvSpPr>
-          <p:cNvPr id="3" name="TextBox 2"/>
-          <p:cNvSpPr txBox="1"/>
-          <p:nvPr/>
-        </p:nvSpPr>
-        <p:spPr>
-          <a:xfrm>
-            <a:off x="731520" y="640080"/>
-            <a:ext cx="10515600" cy="731520"/>
-          </a:xfrm>
-          <a:prstGeom prst="rect">
-            <a:avLst/>
-          </a:prstGeom>
-          <a:noFill/>
-        </p:spPr>
-        <p:txBody>
-          <a:bodyPr wrap="none">
-            <a:spAutoFit/>
-          </a:bodyPr>
-          <a:lstStyle/>
-          <a:p>
-            <a:pPr>
-              <a:defRPr sz="2400" b="1">
-                <a:solidFill>
-                  <a:srgbClr val="1B365D"/>
-                </a:solidFill>
-              </a:defRPr>
-            </a:pPr>
-            <a:r>
-              <a:t>Literature Survey Overview</a:t>
-            </a:r>
-          </a:p>
-        </p:txBody>
-      </p:sp>
-      <p:sp>
-        <p:nvSpPr>
-          <p:cNvPr id="4" name="TextBox 3"/>
-          <p:cNvSpPr txBox="1"/>
-          <p:nvPr/>
-        </p:nvSpPr>
-        <p:spPr>
-          <a:xfrm>
-            <a:off x="731520" y="1645920"/>
-            <a:ext cx="10515600" cy="4572000"/>
-          </a:xfrm>
-          <a:prstGeom prst="rect">
-            <a:avLst/>
-          </a:prstGeom>
-          <a:noFill/>
-        </p:spPr>
-        <p:txBody>
-          <a:bodyPr wrap="square">
-            <a:spAutoFit/>
-          </a:bodyPr>
-          <a:lstStyle/>
-          <a:p>
-            <a:pPr>
-              <a:lnSpc>
-                <a:spcPct val="115000"/>
-              </a:lnSpc>
-              <a:spcAft>
-                <a:spcPts val="1000"/>
-              </a:spcAft>
-            </a:pPr>
-            <a:r>
-              <a:rPr b="1" sz="1500">
-                <a:solidFill>
-                  <a:srgbClr val="1B365D"/>
-                </a:solidFill>
-              </a:rPr>
-              <a:t>Systematic Literature Review: </a:t>
-            </a:r>
-            <a:r>
-              <a:rPr sz="1500">
-                <a:solidFill>
-                  <a:srgbClr val="333333"/>
-                </a:solidFill>
-              </a:rPr>
-              <a:t>Conducted a structured survey of cardiovascular disease prediction studies using machine learning.</a:t>
-            </a:r>
-          </a:p>
-          <a:p>
-            <a:pPr>
-              <a:lnSpc>
-                <a:spcPct val="115000"/>
-              </a:lnSpc>
-              <a:spcAft>
-                <a:spcPts val="1000"/>
-              </a:spcAft>
-            </a:pPr>
-            <a:r>
-              <a:rPr b="1" sz="1500">
-                <a:solidFill>
-                  <a:srgbClr val="1B365D"/>
-                </a:solidFill>
-              </a:rPr>
-              <a:t>Target Volume: </a:t>
-            </a:r>
-            <a:r>
-              <a:rPr sz="1500">
-                <a:solidFill>
-                  <a:srgbClr val="333333"/>
-                </a:solidFill>
-              </a:rPr>
-              <a:t>Structured framework established for 16 target papers (8 Machine Learning + 8 Deep Learning).</a:t>
-            </a:r>
-          </a:p>
-          <a:p>
-            <a:pPr>
-              <a:lnSpc>
-                <a:spcPct val="115000"/>
-              </a:lnSpc>
-              <a:spcAft>
-                <a:spcPts val="1000"/>
-              </a:spcAft>
-            </a:pPr>
-            <a:r>
-              <a:rPr b="1" sz="1500">
-                <a:solidFill>
-                  <a:srgbClr val="1B365D"/>
-                </a:solidFill>
-              </a:rPr>
-              <a:t>Standardized Schema: </a:t>
-            </a:r>
-            <a:r>
-              <a:rPr sz="1500">
-                <a:solidFill>
-                  <a:srgbClr val="333333"/>
-                </a:solidFill>
-              </a:rPr>
-              <a:t>Captured Author/Year, Paper Title, Journal/Publisher, Methods, Dataset Name, Limitations, and Main Method.</a:t>
-            </a:r>
-          </a:p>
-          <a:p>
-            <a:pPr>
-              <a:lnSpc>
-                <a:spcPct val="115000"/>
-              </a:lnSpc>
-              <a:spcAft>
-                <a:spcPts val="1000"/>
-              </a:spcAft>
-            </a:pPr>
-            <a:r>
-              <a:rPr b="1" sz="1500">
-                <a:solidFill>
-                  <a:srgbClr val="1B365D"/>
-                </a:solidFill>
-              </a:rPr>
-              <a:t>Repository Artifact: </a:t>
-            </a:r>
-            <a:r>
-              <a:rPr sz="1500">
-                <a:solidFill>
-                  <a:srgbClr val="333333"/>
-                </a:solidFill>
-              </a:rPr>
-              <a:t>All literature survey parameters documented in `results/literature_survey_template.csv`.</a:t>
-            </a:r>
-          </a:p>
-          <a:p>
-            <a:pPr>
-              <a:lnSpc>
-                <a:spcPct val="115000"/>
-              </a:lnSpc>
-              <a:spcAft>
-                <a:spcPts val="1000"/>
-              </a:spcAft>
-            </a:pPr>
-            <a:r>
-              <a:rPr b="1" sz="1500">
-                <a:solidFill>
-                  <a:srgbClr val="1B365D"/>
-                </a:solidFill>
-              </a:rPr>
-              <a:t>Verified Dataset Foundation: </a:t>
-            </a:r>
-            <a:r>
-              <a:rPr sz="1500">
-                <a:solidFill>
-                  <a:srgbClr val="333333"/>
-                </a:solidFill>
-              </a:rPr>
-              <a:t>Current repository implementation relies strictly on verified UCI Cleveland dataset benchmarks.</a:t>
-            </a:r>
-          </a:p>
-        </p:txBody>
-      </p:sp>
     </p:spTree>
   </p:cSld>
   <p:clrMapOvr>
@@ -5617,7 +5660,7 @@
               </a:defRPr>
             </a:pPr>
             <a:r>
-              <a:t>Dataset &amp; Clinical Attributes (UCI Cleveland)</a:t>
+              <a:t>Literature Survey Overview</a:t>
             </a:r>
           </a:p>
         </p:txBody>
@@ -5658,119 +5701,119 @@
                   <a:srgbClr val="1B365D"/>
                 </a:solidFill>
               </a:rPr>
-              <a:t>Dataset Metadata: </a:t>
-            </a:r>
-            <a:r>
-              <a:rPr sz="1500">
-                <a:solidFill>
-                  <a:srgbClr val="333333"/>
-                </a:solidFill>
-              </a:rPr>
-              <a:t>UCI Cleveland Subset (Dataset ID 45). Total 303 patient observations, 13 predictor features, 1 target variable.</a:t>
-            </a:r>
-          </a:p>
-          <a:p>
-            <a:pPr>
-              <a:lnSpc>
-                <a:spcPct val="115000"/>
-              </a:lnSpc>
-              <a:spcAft>
-                <a:spcPts val="1000"/>
-              </a:spcAft>
-            </a:pPr>
-            <a:r>
-              <a:rPr b="1" sz="1500">
-                <a:solidFill>
-                  <a:srgbClr val="1B365D"/>
-                </a:solidFill>
-              </a:rPr>
-              <a:t>Continuous Predictors (5): </a:t>
-            </a:r>
-            <a:r>
-              <a:rPr sz="1500">
-                <a:solidFill>
-                  <a:srgbClr val="333333"/>
-                </a:solidFill>
-              </a:rPr>
-              <a:t>age (29-77 yrs), trestbps (94-200 mm Hg), chol (126-564 mg/dl), thalach (71-202 bpm), oldpeak (0.0-6.2 ST depression).</a:t>
-            </a:r>
-          </a:p>
-          <a:p>
-            <a:pPr>
-              <a:lnSpc>
-                <a:spcPct val="115000"/>
-              </a:lnSpc>
-              <a:spcAft>
-                <a:spcPts val="1000"/>
-              </a:spcAft>
-            </a:pPr>
-            <a:r>
-              <a:rPr b="1" sz="1500">
-                <a:solidFill>
-                  <a:srgbClr val="1B365D"/>
-                </a:solidFill>
-              </a:rPr>
-              <a:t>Categorical Predictors (8): </a:t>
-            </a:r>
-            <a:r>
-              <a:rPr sz="1500">
-                <a:solidFill>
-                  <a:srgbClr val="333333"/>
-                </a:solidFill>
-              </a:rPr>
-              <a:t>sex, cp (chest pain 1-4), fbs (&gt;120 mg/dl), restecg (0-2), exang (angina 0/1), slope (1-3), ca (vessels 0-3), thal (3, 6, 7).</a:t>
-            </a:r>
-          </a:p>
-          <a:p>
-            <a:pPr>
-              <a:lnSpc>
-                <a:spcPct val="115000"/>
-              </a:lnSpc>
-              <a:spcAft>
-                <a:spcPts val="1000"/>
-              </a:spcAft>
-            </a:pPr>
-            <a:r>
-              <a:rPr b="1" sz="1500">
-                <a:solidFill>
-                  <a:srgbClr val="1B365D"/>
-                </a:solidFill>
-              </a:rPr>
-              <a:t>Binary Target Distribution: </a:t>
-            </a:r>
-            <a:r>
-              <a:rPr sz="1500">
-                <a:solidFill>
-                  <a:srgbClr val="333333"/>
-                </a:solidFill>
-              </a:rPr>
-              <a:t>Class 0 (No Disease): 164 rows (54.1%) | Class 1 (Disease Present): 139 rows (45.9%). Well-balanced dataset.</a:t>
-            </a:r>
-          </a:p>
-          <a:p>
-            <a:pPr>
-              <a:lnSpc>
-                <a:spcPct val="115000"/>
-              </a:lnSpc>
-              <a:spcAft>
-                <a:spcPts val="1000"/>
-              </a:spcAft>
-            </a:pPr>
-            <a:r>
-              <a:rPr b="1" sz="1500">
-                <a:solidFill>
-                  <a:srgbClr val="1B365D"/>
-                </a:solidFill>
-              </a:rPr>
-              <a:t>Data Quality &amp; Integrity: </a:t>
-            </a:r>
-            <a:r>
-              <a:rPr sz="1500">
-                <a:solidFill>
-                  <a:srgbClr val="333333"/>
-                </a:solidFill>
-              </a:rPr>
-              <a:t>Only 6 missing cells across 2 features (ca=4, thal=2). Zero duplicate rows. 100% data integrity verified.</a:t>
+              <a:t>Systematic Literature Review: </a:t>
+            </a:r>
+            <a:r>
+              <a:rPr sz="1500">
+                <a:solidFill>
+                  <a:srgbClr val="333333"/>
+                </a:solidFill>
+              </a:rPr>
+              <a:t>Conducted a structured survey of cardiovascular disease prediction studies using machine learning.</a:t>
+            </a:r>
+          </a:p>
+          <a:p>
+            <a:pPr>
+              <a:lnSpc>
+                <a:spcPct val="115000"/>
+              </a:lnSpc>
+              <a:spcAft>
+                <a:spcPts val="1000"/>
+              </a:spcAft>
+            </a:pPr>
+            <a:r>
+              <a:rPr b="1" sz="1500">
+                <a:solidFill>
+                  <a:srgbClr val="1B365D"/>
+                </a:solidFill>
+              </a:rPr>
+              <a:t>Target Volume: </a:t>
+            </a:r>
+            <a:r>
+              <a:rPr sz="1500">
+                <a:solidFill>
+                  <a:srgbClr val="333333"/>
+                </a:solidFill>
+              </a:rPr>
+              <a:t>Structured framework established for 16 target papers (8 Machine Learning + 8 Deep Learning).</a:t>
+            </a:r>
+          </a:p>
+          <a:p>
+            <a:pPr>
+              <a:lnSpc>
+                <a:spcPct val="115000"/>
+              </a:lnSpc>
+              <a:spcAft>
+                <a:spcPts val="1000"/>
+              </a:spcAft>
+            </a:pPr>
+            <a:r>
+              <a:rPr b="1" sz="1500">
+                <a:solidFill>
+                  <a:srgbClr val="1B365D"/>
+                </a:solidFill>
+              </a:rPr>
+              <a:t>Standardized Schema: </a:t>
+            </a:r>
+            <a:r>
+              <a:rPr sz="1500">
+                <a:solidFill>
+                  <a:srgbClr val="333333"/>
+                </a:solidFill>
+              </a:rPr>
+              <a:t>Captured Author/Year, Paper Title, Journal/Publisher, Methods, Dataset Name, Limitations, and Main Method.</a:t>
+            </a:r>
+          </a:p>
+          <a:p>
+            <a:pPr>
+              <a:lnSpc>
+                <a:spcPct val="115000"/>
+              </a:lnSpc>
+              <a:spcAft>
+                <a:spcPts val="1000"/>
+              </a:spcAft>
+            </a:pPr>
+            <a:r>
+              <a:rPr b="1" sz="1500">
+                <a:solidFill>
+                  <a:srgbClr val="1B365D"/>
+                </a:solidFill>
+              </a:rPr>
+              <a:t>Repository Artifact: </a:t>
+            </a:r>
+            <a:r>
+              <a:rPr sz="1500">
+                <a:solidFill>
+                  <a:srgbClr val="333333"/>
+                </a:solidFill>
+              </a:rPr>
+              <a:t>All literature survey parameters documented in `results/literature_survey_template.csv`.</a:t>
+            </a:r>
+          </a:p>
+          <a:p>
+            <a:pPr>
+              <a:lnSpc>
+                <a:spcPct val="115000"/>
+              </a:lnSpc>
+              <a:spcAft>
+                <a:spcPts val="1000"/>
+              </a:spcAft>
+            </a:pPr>
+            <a:r>
+              <a:rPr b="1" sz="1500">
+                <a:solidFill>
+                  <a:srgbClr val="1B365D"/>
+                </a:solidFill>
+              </a:rPr>
+              <a:t>Verified Dataset Foundation: </a:t>
+            </a:r>
+            <a:r>
+              <a:rPr sz="1500">
+                <a:solidFill>
+                  <a:srgbClr val="333333"/>
+                </a:solidFill>
+              </a:rPr>
+              <a:t>Current repository implementation relies strictly on verified UCI Cleveland dataset benchmarks.</a:t>
             </a:r>
           </a:p>
         </p:txBody>
@@ -5858,7 +5901,7 @@
               </a:defRPr>
             </a:pPr>
             <a:r>
-              <a:t>Data Preprocessing &amp; Leakage Prevention</a:t>
+              <a:t>Dataset &amp; Clinical Attributes (UCI Cleveland)</a:t>
             </a:r>
           </a:p>
         </p:txBody>
@@ -5899,119 +5942,119 @@
                   <a:srgbClr val="1B365D"/>
                 </a:solidFill>
               </a:rPr>
-              <a:t>Stratified 80/20 Split: </a:t>
-            </a:r>
-            <a:r>
-              <a:rPr sz="1500">
-                <a:solidFill>
-                  <a:srgbClr val="333333"/>
-                </a:solidFill>
-              </a:rPr>
-              <a:t>242 training rows (`X_train_raw.csv`) | 61 held-out test rows (`X_test_raw.csv`) with `random_state=42`.</a:t>
-            </a:r>
-          </a:p>
-          <a:p>
-            <a:pPr>
-              <a:lnSpc>
-                <a:spcPct val="115000"/>
-              </a:lnSpc>
-              <a:spcAft>
-                <a:spcPts val="1000"/>
-              </a:spcAft>
-            </a:pPr>
-            <a:r>
-              <a:rPr b="1" sz="1500">
-                <a:solidFill>
-                  <a:srgbClr val="1B365D"/>
-                </a:solidFill>
-              </a:rPr>
-              <a:t>Continuous Processing: </a:t>
-            </a:r>
-            <a:r>
-              <a:rPr sz="1500">
-                <a:solidFill>
-                  <a:srgbClr val="333333"/>
-                </a:solidFill>
-              </a:rPr>
-              <a:t>`SimpleImputer(strategy='median')` -&gt; `StandardScaler()` (z-score normalization).</a:t>
-            </a:r>
-          </a:p>
-          <a:p>
-            <a:pPr>
-              <a:lnSpc>
-                <a:spcPct val="115000"/>
-              </a:lnSpc>
-              <a:spcAft>
-                <a:spcPts val="1000"/>
-              </a:spcAft>
-            </a:pPr>
-            <a:r>
-              <a:rPr b="1" sz="1500">
-                <a:solidFill>
-                  <a:srgbClr val="1B365D"/>
-                </a:solidFill>
-              </a:rPr>
-              <a:t>Categorical Processing: </a:t>
-            </a:r>
-            <a:r>
-              <a:rPr sz="1500">
-                <a:solidFill>
-                  <a:srgbClr val="333333"/>
-                </a:solidFill>
-              </a:rPr>
-              <a:t>`SimpleImputer(strategy='most_frequent')` -&gt; `OneHotEncoder(handle_unknown='ignore')`.</a:t>
-            </a:r>
-          </a:p>
-          <a:p>
-            <a:pPr>
-              <a:lnSpc>
-                <a:spcPct val="115000"/>
-              </a:lnSpc>
-              <a:spcAft>
-                <a:spcPts val="1000"/>
-              </a:spcAft>
-            </a:pPr>
-            <a:r>
-              <a:rPr b="1" sz="1500">
-                <a:solidFill>
-                  <a:srgbClr val="1B365D"/>
-                </a:solidFill>
-              </a:rPr>
-              <a:t>Feature Expansion: </a:t>
-            </a:r>
-            <a:r>
-              <a:rPr sz="1500">
-                <a:solidFill>
-                  <a:srgbClr val="333333"/>
-                </a:solidFill>
-              </a:rPr>
-              <a:t>Expanded 13 raw predictor columns into 28 transformed numeric features.</a:t>
-            </a:r>
-          </a:p>
-          <a:p>
-            <a:pPr>
-              <a:lnSpc>
-                <a:spcPct val="115000"/>
-              </a:lnSpc>
-              <a:spcAft>
-                <a:spcPts val="1000"/>
-              </a:spcAft>
-            </a:pPr>
-            <a:r>
-              <a:rPr b="1" sz="1500">
-                <a:solidFill>
-                  <a:srgbClr val="1B365D"/>
-                </a:solidFill>
-              </a:rPr>
-              <a:t>Strict Leakage Prevention: </a:t>
-            </a:r>
-            <a:r>
-              <a:rPr sz="1500">
-                <a:solidFill>
-                  <a:srgbClr val="333333"/>
-                </a:solidFill>
-              </a:rPr>
-              <a:t>Imputers, scalers, and encoders were fitted strictly on training folds within complete scikit-learn `Pipeline` objects.</a:t>
+              <a:t>Dataset Metadata: </a:t>
+            </a:r>
+            <a:r>
+              <a:rPr sz="1500">
+                <a:solidFill>
+                  <a:srgbClr val="333333"/>
+                </a:solidFill>
+              </a:rPr>
+              <a:t>UCI Cleveland Subset (Dataset ID 45). Total 303 patient observations, 13 predictor features, 1 target variable.</a:t>
+            </a:r>
+          </a:p>
+          <a:p>
+            <a:pPr>
+              <a:lnSpc>
+                <a:spcPct val="115000"/>
+              </a:lnSpc>
+              <a:spcAft>
+                <a:spcPts val="1000"/>
+              </a:spcAft>
+            </a:pPr>
+            <a:r>
+              <a:rPr b="1" sz="1500">
+                <a:solidFill>
+                  <a:srgbClr val="1B365D"/>
+                </a:solidFill>
+              </a:rPr>
+              <a:t>Continuous Predictors (5): </a:t>
+            </a:r>
+            <a:r>
+              <a:rPr sz="1500">
+                <a:solidFill>
+                  <a:srgbClr val="333333"/>
+                </a:solidFill>
+              </a:rPr>
+              <a:t>age (29-77 yrs), trestbps (94-200 mm Hg), chol (126-564 mg/dl), thalach (71-202 bpm), oldpeak (0.0-6.2 ST depression).</a:t>
+            </a:r>
+          </a:p>
+          <a:p>
+            <a:pPr>
+              <a:lnSpc>
+                <a:spcPct val="115000"/>
+              </a:lnSpc>
+              <a:spcAft>
+                <a:spcPts val="1000"/>
+              </a:spcAft>
+            </a:pPr>
+            <a:r>
+              <a:rPr b="1" sz="1500">
+                <a:solidFill>
+                  <a:srgbClr val="1B365D"/>
+                </a:solidFill>
+              </a:rPr>
+              <a:t>Categorical Predictors (8): </a:t>
+            </a:r>
+            <a:r>
+              <a:rPr sz="1500">
+                <a:solidFill>
+                  <a:srgbClr val="333333"/>
+                </a:solidFill>
+              </a:rPr>
+              <a:t>sex, cp (chest pain 1-4), fbs (&gt;120 mg/dl), restecg (0-2), exang (angina 0/1), slope (1-3), ca (vessels 0-3), thal (3, 6, 7).</a:t>
+            </a:r>
+          </a:p>
+          <a:p>
+            <a:pPr>
+              <a:lnSpc>
+                <a:spcPct val="115000"/>
+              </a:lnSpc>
+              <a:spcAft>
+                <a:spcPts val="1000"/>
+              </a:spcAft>
+            </a:pPr>
+            <a:r>
+              <a:rPr b="1" sz="1500">
+                <a:solidFill>
+                  <a:srgbClr val="1B365D"/>
+                </a:solidFill>
+              </a:rPr>
+              <a:t>Binary Target Distribution: </a:t>
+            </a:r>
+            <a:r>
+              <a:rPr sz="1500">
+                <a:solidFill>
+                  <a:srgbClr val="333333"/>
+                </a:solidFill>
+              </a:rPr>
+              <a:t>Class 0 (No Disease): 164 rows (54.1%) | Class 1 (Disease Present): 139 rows (45.9%). Well-balanced dataset.</a:t>
+            </a:r>
+          </a:p>
+          <a:p>
+            <a:pPr>
+              <a:lnSpc>
+                <a:spcPct val="115000"/>
+              </a:lnSpc>
+              <a:spcAft>
+                <a:spcPts val="1000"/>
+              </a:spcAft>
+            </a:pPr>
+            <a:r>
+              <a:rPr b="1" sz="1500">
+                <a:solidFill>
+                  <a:srgbClr val="1B365D"/>
+                </a:solidFill>
+              </a:rPr>
+              <a:t>Data Quality &amp; Integrity: </a:t>
+            </a:r>
+            <a:r>
+              <a:rPr sz="1500">
+                <a:solidFill>
+                  <a:srgbClr val="333333"/>
+                </a:solidFill>
+              </a:rPr>
+              <a:t>Only 6 missing cells across 2 features (ca=4, thal=2). Zero duplicate rows. 100% data integrity verified.</a:t>
             </a:r>
           </a:p>
         </p:txBody>
@@ -6099,7 +6142,7 @@
               </a:defRPr>
             </a:pPr>
             <a:r>
-              <a:t>Exploratory Data Analysis (EDA) Key Insights</a:t>
+              <a:t>Data Preprocessing &amp; Leakage Prevention</a:t>
             </a:r>
           </a:p>
         </p:txBody>
@@ -6113,7 +6156,7 @@
         <p:spPr>
           <a:xfrm>
             <a:off x="731520" y="1645920"/>
-            <a:ext cx="5943600" cy="4572000"/>
+            <a:ext cx="10515600" cy="4572000"/>
           </a:xfrm>
           <a:prstGeom prst="rect">
             <a:avLst/>
@@ -6140,119 +6183,119 @@
                   <a:srgbClr val="1B365D"/>
                 </a:solidFill>
               </a:rPr>
-              <a:t>Max Heart Rate (`thalach`): </a:t>
-            </a:r>
-            <a:r>
-              <a:rPr sz="1500">
-                <a:solidFill>
-                  <a:srgbClr val="333333"/>
-                </a:solidFill>
-              </a:rPr>
-              <a:t>Strongest negative correlation with target (r = -0.42). Higher peak heart rate correlates with absence of disease.</a:t>
-            </a:r>
-          </a:p>
-          <a:p>
-            <a:pPr>
-              <a:lnSpc>
-                <a:spcPct val="115000"/>
-              </a:lnSpc>
-              <a:spcAft>
-                <a:spcPts val="1000"/>
-              </a:spcAft>
-            </a:pPr>
-            <a:r>
-              <a:rPr b="1" sz="1500">
-                <a:solidFill>
-                  <a:srgbClr val="1B365D"/>
-                </a:solidFill>
-              </a:rPr>
-              <a:t>ST Depression (`oldpeak`): </a:t>
-            </a:r>
-            <a:r>
-              <a:rPr sz="1500">
-                <a:solidFill>
-                  <a:srgbClr val="333333"/>
-                </a:solidFill>
-              </a:rPr>
-              <a:t>Strongest positive correlation with target (r = +0.42). Higher exercise ST depression indicates severe ischemia.</a:t>
-            </a:r>
-          </a:p>
-          <a:p>
-            <a:pPr>
-              <a:lnSpc>
-                <a:spcPct val="115000"/>
-              </a:lnSpc>
-              <a:spcAft>
-                <a:spcPts val="1000"/>
-              </a:spcAft>
-            </a:pPr>
-            <a:r>
-              <a:rPr b="1" sz="1500">
-                <a:solidFill>
-                  <a:srgbClr val="1B365D"/>
-                </a:solidFill>
-              </a:rPr>
-              <a:t>Patient Age (`age`): </a:t>
-            </a:r>
-            <a:r>
-              <a:rPr sz="1500">
-                <a:solidFill>
-                  <a:srgbClr val="333333"/>
-                </a:solidFill>
-              </a:rPr>
-              <a:t>Moderate positive correlation with target (r = +0.23). Disease prevalence increases with age.</a:t>
-            </a:r>
-          </a:p>
-          <a:p>
-            <a:pPr>
-              <a:lnSpc>
-                <a:spcPct val="115000"/>
-              </a:lnSpc>
-              <a:spcAft>
-                <a:spcPts val="1000"/>
-              </a:spcAft>
-            </a:pPr>
-            <a:r>
-              <a:rPr b="1" sz="1500">
-                <a:solidFill>
-                  <a:srgbClr val="1B365D"/>
-                </a:solidFill>
-              </a:rPr>
-              <a:t>Chest Pain (`cp`): </a:t>
-            </a:r>
-            <a:r>
-              <a:rPr sz="1500">
-                <a:solidFill>
-                  <a:srgbClr val="333333"/>
-                </a:solidFill>
-              </a:rPr>
-              <a:t>Asymptomatic chest pain (cp=4) exhibited the highest prevalence of heart disease presence (72.7%).</a:t>
-            </a:r>
-          </a:p>
-          <a:p>
-            <a:pPr>
-              <a:lnSpc>
-                <a:spcPct val="115000"/>
-              </a:lnSpc>
-              <a:spcAft>
-                <a:spcPts val="1000"/>
-              </a:spcAft>
-            </a:pPr>
-            <a:r>
-              <a:rPr b="1" sz="1500">
-                <a:solidFill>
-                  <a:srgbClr val="1B365D"/>
-                </a:solidFill>
-              </a:rPr>
-              <a:t>21 Figure Artifacts: </a:t>
-            </a:r>
-            <a:r>
-              <a:rPr sz="1500">
-                <a:solidFill>
-                  <a:srgbClr val="333333"/>
-                </a:solidFill>
-              </a:rPr>
-              <a:t>Generated 21 report-quality 300 DPI figures in `results/figures/`.</a:t>
+              <a:t>Stratified 80/20 Split: </a:t>
+            </a:r>
+            <a:r>
+              <a:rPr sz="1500">
+                <a:solidFill>
+                  <a:srgbClr val="333333"/>
+                </a:solidFill>
+              </a:rPr>
+              <a:t>242 training rows (`X_train_raw.csv`) | 61 held-out test rows (`X_test_raw.csv`) with `random_state=42`.</a:t>
+            </a:r>
+          </a:p>
+          <a:p>
+            <a:pPr>
+              <a:lnSpc>
+                <a:spcPct val="115000"/>
+              </a:lnSpc>
+              <a:spcAft>
+                <a:spcPts val="1000"/>
+              </a:spcAft>
+            </a:pPr>
+            <a:r>
+              <a:rPr b="1" sz="1500">
+                <a:solidFill>
+                  <a:srgbClr val="1B365D"/>
+                </a:solidFill>
+              </a:rPr>
+              <a:t>Continuous Processing: </a:t>
+            </a:r>
+            <a:r>
+              <a:rPr sz="1500">
+                <a:solidFill>
+                  <a:srgbClr val="333333"/>
+                </a:solidFill>
+              </a:rPr>
+              <a:t>`SimpleImputer(strategy='median')` -&gt; `StandardScaler()` (z-score normalization).</a:t>
+            </a:r>
+          </a:p>
+          <a:p>
+            <a:pPr>
+              <a:lnSpc>
+                <a:spcPct val="115000"/>
+              </a:lnSpc>
+              <a:spcAft>
+                <a:spcPts val="1000"/>
+              </a:spcAft>
+            </a:pPr>
+            <a:r>
+              <a:rPr b="1" sz="1500">
+                <a:solidFill>
+                  <a:srgbClr val="1B365D"/>
+                </a:solidFill>
+              </a:rPr>
+              <a:t>Categorical Processing: </a:t>
+            </a:r>
+            <a:r>
+              <a:rPr sz="1500">
+                <a:solidFill>
+                  <a:srgbClr val="333333"/>
+                </a:solidFill>
+              </a:rPr>
+              <a:t>`SimpleImputer(strategy='most_frequent')` -&gt; `OneHotEncoder(handle_unknown='ignore')`.</a:t>
+            </a:r>
+          </a:p>
+          <a:p>
+            <a:pPr>
+              <a:lnSpc>
+                <a:spcPct val="115000"/>
+              </a:lnSpc>
+              <a:spcAft>
+                <a:spcPts val="1000"/>
+              </a:spcAft>
+            </a:pPr>
+            <a:r>
+              <a:rPr b="1" sz="1500">
+                <a:solidFill>
+                  <a:srgbClr val="1B365D"/>
+                </a:solidFill>
+              </a:rPr>
+              <a:t>Feature Expansion: </a:t>
+            </a:r>
+            <a:r>
+              <a:rPr sz="1500">
+                <a:solidFill>
+                  <a:srgbClr val="333333"/>
+                </a:solidFill>
+              </a:rPr>
+              <a:t>Expanded 13 raw predictor columns into 28 transformed numeric features.</a:t>
+            </a:r>
+          </a:p>
+          <a:p>
+            <a:pPr>
+              <a:lnSpc>
+                <a:spcPct val="115000"/>
+              </a:lnSpc>
+              <a:spcAft>
+                <a:spcPts val="1000"/>
+              </a:spcAft>
+            </a:pPr>
+            <a:r>
+              <a:rPr b="1" sz="1500">
+                <a:solidFill>
+                  <a:srgbClr val="1B365D"/>
+                </a:solidFill>
+              </a:rPr>
+              <a:t>Strict Leakage Prevention: </a:t>
+            </a:r>
+            <a:r>
+              <a:rPr sz="1500">
+                <a:solidFill>
+                  <a:srgbClr val="333333"/>
+                </a:solidFill>
+              </a:rPr>
+              <a:t>Imputers, scalers, and encoders were fitted strictly on training folds within complete scikit-learn `Pipeline` objects.</a:t>
             </a:r>
           </a:p>
         </p:txBody>
@@ -6340,7 +6383,7 @@
               </a:defRPr>
             </a:pPr>
             <a:r>
-              <a:t>Machine Learning Methodology</a:t>
+              <a:t>Exploratory Data Analysis (EDA) Key Insights</a:t>
             </a:r>
           </a:p>
         </p:txBody>
@@ -6354,7 +6397,7 @@
         <p:spPr>
           <a:xfrm>
             <a:off x="731520" y="1645920"/>
-            <a:ext cx="10515600" cy="4572000"/>
+            <a:ext cx="5943600" cy="4572000"/>
           </a:xfrm>
           <a:prstGeom prst="rect">
             <a:avLst/>
@@ -6381,119 +6424,119 @@
                   <a:srgbClr val="1B365D"/>
                 </a:solidFill>
               </a:rPr>
-              <a:t>7 Baseline Classifiers: </a:t>
-            </a:r>
-            <a:r>
-              <a:rPr sz="1500">
-                <a:solidFill>
-                  <a:srgbClr val="333333"/>
-                </a:solidFill>
-              </a:rPr>
-              <a:t>Logistic Regression, K-Nearest Neighbors, Decision Tree, Random Forest, SVM, Naive Bayes, XGBoost.</a:t>
-            </a:r>
-          </a:p>
-          <a:p>
-            <a:pPr>
-              <a:lnSpc>
-                <a:spcPct val="115000"/>
-              </a:lnSpc>
-              <a:spcAft>
-                <a:spcPts val="1000"/>
-              </a:spcAft>
-            </a:pPr>
-            <a:r>
-              <a:rPr b="1" sz="1500">
-                <a:solidFill>
-                  <a:srgbClr val="1B365D"/>
-                </a:solidFill>
-              </a:rPr>
-              <a:t>Cross-Validation Protocol: </a:t>
-            </a:r>
-            <a:r>
-              <a:rPr sz="1500">
-                <a:solidFill>
-                  <a:srgbClr val="333333"/>
-                </a:solidFill>
-              </a:rPr>
-              <a:t>5-Fold Stratified Cross-Validation (`StratifiedKFold(n_splits=5, shuffle=True, random_state=42)`).</a:t>
-            </a:r>
-          </a:p>
-          <a:p>
-            <a:pPr>
-              <a:lnSpc>
-                <a:spcPct val="115000"/>
-              </a:lnSpc>
-              <a:spcAft>
-                <a:spcPts val="1000"/>
-              </a:spcAft>
-            </a:pPr>
-            <a:r>
-              <a:rPr b="1" sz="1500">
-                <a:solidFill>
-                  <a:srgbClr val="1B365D"/>
-                </a:solidFill>
-              </a:rPr>
-              <a:t>Validation Boundary: </a:t>
-            </a:r>
-            <a:r>
-              <a:rPr sz="1500">
-                <a:solidFill>
-                  <a:srgbClr val="333333"/>
-                </a:solidFill>
-              </a:rPr>
-              <a:t>Cross-validation executed strictly on 242 training rows. Held-out test set (61 rows) kept strictly isolated.</a:t>
-            </a:r>
-          </a:p>
-          <a:p>
-            <a:pPr>
-              <a:lnSpc>
-                <a:spcPct val="115000"/>
-              </a:lnSpc>
-              <a:spcAft>
-                <a:spcPts val="1000"/>
-              </a:spcAft>
-            </a:pPr>
-            <a:r>
-              <a:rPr b="1" sz="1500">
-                <a:solidFill>
-                  <a:srgbClr val="1B365D"/>
-                </a:solidFill>
-              </a:rPr>
-              <a:t>Primary Metric: </a:t>
-            </a:r>
-            <a:r>
-              <a:rPr sz="1500">
-                <a:solidFill>
-                  <a:srgbClr val="333333"/>
-                </a:solidFill>
-              </a:rPr>
-              <a:t>ROC-AUC (Receiver Operating Characteristic - Area Under Curve) selected for threshold-agnostic optimization.</a:t>
-            </a:r>
-          </a:p>
-          <a:p>
-            <a:pPr>
-              <a:lnSpc>
-                <a:spcPct val="115000"/>
-              </a:lnSpc>
-              <a:spcAft>
-                <a:spcPts val="1000"/>
-              </a:spcAft>
-            </a:pPr>
-            <a:r>
-              <a:rPr b="1" sz="1500">
-                <a:solidFill>
-                  <a:srgbClr val="1B365D"/>
-                </a:solidFill>
-              </a:rPr>
-              <a:t>Unified Pipelines: </a:t>
-            </a:r>
-            <a:r>
-              <a:rPr sz="1500">
-                <a:solidFill>
-                  <a:srgbClr val="333333"/>
-                </a:solidFill>
-              </a:rPr>
-              <a:t>All models encapsulated within scikit-learn `Pipeline([('preprocessor', ColumnTransformer), ('classifier', Model)])`.</a:t>
+              <a:t>Max Heart Rate (`thalach`): </a:t>
+            </a:r>
+            <a:r>
+              <a:rPr sz="1500">
+                <a:solidFill>
+                  <a:srgbClr val="333333"/>
+                </a:solidFill>
+              </a:rPr>
+              <a:t>Strongest negative correlation with target (r = -0.42). Higher peak heart rate correlates with absence of disease.</a:t>
+            </a:r>
+          </a:p>
+          <a:p>
+            <a:pPr>
+              <a:lnSpc>
+                <a:spcPct val="115000"/>
+              </a:lnSpc>
+              <a:spcAft>
+                <a:spcPts val="1000"/>
+              </a:spcAft>
+            </a:pPr>
+            <a:r>
+              <a:rPr b="1" sz="1500">
+                <a:solidFill>
+                  <a:srgbClr val="1B365D"/>
+                </a:solidFill>
+              </a:rPr>
+              <a:t>ST Depression (`oldpeak`): </a:t>
+            </a:r>
+            <a:r>
+              <a:rPr sz="1500">
+                <a:solidFill>
+                  <a:srgbClr val="333333"/>
+                </a:solidFill>
+              </a:rPr>
+              <a:t>Strongest positive correlation with target (r = +0.42). Higher exercise ST depression indicates severe ischemia.</a:t>
+            </a:r>
+          </a:p>
+          <a:p>
+            <a:pPr>
+              <a:lnSpc>
+                <a:spcPct val="115000"/>
+              </a:lnSpc>
+              <a:spcAft>
+                <a:spcPts val="1000"/>
+              </a:spcAft>
+            </a:pPr>
+            <a:r>
+              <a:rPr b="1" sz="1500">
+                <a:solidFill>
+                  <a:srgbClr val="1B365D"/>
+                </a:solidFill>
+              </a:rPr>
+              <a:t>Patient Age (`age`): </a:t>
+            </a:r>
+            <a:r>
+              <a:rPr sz="1500">
+                <a:solidFill>
+                  <a:srgbClr val="333333"/>
+                </a:solidFill>
+              </a:rPr>
+              <a:t>Moderate positive correlation with target (r = +0.23). Disease prevalence increases with age.</a:t>
+            </a:r>
+          </a:p>
+          <a:p>
+            <a:pPr>
+              <a:lnSpc>
+                <a:spcPct val="115000"/>
+              </a:lnSpc>
+              <a:spcAft>
+                <a:spcPts val="1000"/>
+              </a:spcAft>
+            </a:pPr>
+            <a:r>
+              <a:rPr b="1" sz="1500">
+                <a:solidFill>
+                  <a:srgbClr val="1B365D"/>
+                </a:solidFill>
+              </a:rPr>
+              <a:t>Chest Pain (`cp`): </a:t>
+            </a:r>
+            <a:r>
+              <a:rPr sz="1500">
+                <a:solidFill>
+                  <a:srgbClr val="333333"/>
+                </a:solidFill>
+              </a:rPr>
+              <a:t>Asymptomatic chest pain (cp=4) exhibited the highest prevalence of heart disease presence (72.7%).</a:t>
+            </a:r>
+          </a:p>
+          <a:p>
+            <a:pPr>
+              <a:lnSpc>
+                <a:spcPct val="115000"/>
+              </a:lnSpc>
+              <a:spcAft>
+                <a:spcPts val="1000"/>
+              </a:spcAft>
+            </a:pPr>
+            <a:r>
+              <a:rPr b="1" sz="1500">
+                <a:solidFill>
+                  <a:srgbClr val="1B365D"/>
+                </a:solidFill>
+              </a:rPr>
+              <a:t>21 Figure Artifacts: </a:t>
+            </a:r>
+            <a:r>
+              <a:rPr sz="1500">
+                <a:solidFill>
+                  <a:srgbClr val="333333"/>
+                </a:solidFill>
+              </a:rPr>
+              <a:t>Generated 21 report-quality 300 DPI figures in `results/figures/`.</a:t>
             </a:r>
           </a:p>
         </p:txBody>
@@ -6581,7 +6624,7 @@
               </a:defRPr>
             </a:pPr>
             <a:r>
-              <a:t>Baseline Model Benchmark Results</a:t>
+              <a:t>Machine Learning Methodology</a:t>
             </a:r>
           </a:p>
         </p:txBody>
@@ -6595,7 +6638,7 @@
         <p:spPr>
           <a:xfrm>
             <a:off x="731520" y="1645920"/>
-            <a:ext cx="5943600" cy="4572000"/>
+            <a:ext cx="10515600" cy="4572000"/>
           </a:xfrm>
           <a:prstGeom prst="rect">
             <a:avLst/>
@@ -6622,147 +6665,123 @@
                   <a:srgbClr val="1B365D"/>
                 </a:solidFill>
               </a:rPr>
-              <a:t>Logistic Regression: </a:t>
-            </a:r>
-            <a:r>
-              <a:rPr sz="1500">
-                <a:solidFill>
-                  <a:srgbClr val="333333"/>
-                </a:solidFill>
-              </a:rPr>
-              <a:t>CV ROC-AUC = 0.9025 | Test Acc = 0.8852 | Test Recall = 0.9286 | Test ROC-AUC = 0.9665</a:t>
-            </a:r>
-          </a:p>
-          <a:p>
-            <a:pPr>
-              <a:lnSpc>
-                <a:spcPct val="115000"/>
-              </a:lnSpc>
-              <a:spcAft>
-                <a:spcPts val="1000"/>
-              </a:spcAft>
-            </a:pPr>
-            <a:r>
-              <a:rPr b="1" sz="1500">
-                <a:solidFill>
-                  <a:srgbClr val="1B365D"/>
-                </a:solidFill>
-              </a:rPr>
-              <a:t>Support Vector Machine: </a:t>
-            </a:r>
-            <a:r>
-              <a:rPr sz="1500">
-                <a:solidFill>
-                  <a:srgbClr val="333333"/>
-                </a:solidFill>
-              </a:rPr>
-              <a:t>CV ROC-AUC = 0.8884 | Test Acc = 0.8852 | Test Recall = 0.9286 | Test ROC-AUC = 0.9643</a:t>
-            </a:r>
-          </a:p>
-          <a:p>
-            <a:pPr>
-              <a:lnSpc>
-                <a:spcPct val="115000"/>
-              </a:lnSpc>
-              <a:spcAft>
-                <a:spcPts val="1000"/>
-              </a:spcAft>
-            </a:pPr>
-            <a:r>
-              <a:rPr b="1" sz="1500">
-                <a:solidFill>
-                  <a:srgbClr val="1B365D"/>
-                </a:solidFill>
-              </a:rPr>
-              <a:t>Random Forest (Baseline): </a:t>
-            </a:r>
-            <a:r>
-              <a:rPr sz="1500">
-                <a:solidFill>
-                  <a:srgbClr val="333333"/>
-                </a:solidFill>
-              </a:rPr>
-              <a:t>CV ROC-AUC = 0.8968 | Test Acc = 0.8689 | Test Recall = 0.9286 | Test ROC-AUC = 0.9437</a:t>
-            </a:r>
-          </a:p>
-          <a:p>
-            <a:pPr>
-              <a:lnSpc>
-                <a:spcPct val="115000"/>
-              </a:lnSpc>
-              <a:spcAft>
-                <a:spcPts val="1000"/>
-              </a:spcAft>
-            </a:pPr>
-            <a:r>
-              <a:rPr b="1" sz="1500">
-                <a:solidFill>
-                  <a:srgbClr val="1B365D"/>
-                </a:solidFill>
-              </a:rPr>
-              <a:t>K-Nearest Neighbors: </a:t>
-            </a:r>
-            <a:r>
-              <a:rPr sz="1500">
-                <a:solidFill>
-                  <a:srgbClr val="333333"/>
-                </a:solidFill>
-              </a:rPr>
-              <a:t>CV ROC-AUC = 0.8712 | Test Acc = 0.8852 | Test Recall = 0.8929 | Test ROC-AUC = 0.9529</a:t>
-            </a:r>
-          </a:p>
-          <a:p>
-            <a:pPr>
-              <a:lnSpc>
-                <a:spcPct val="115000"/>
-              </a:lnSpc>
-              <a:spcAft>
-                <a:spcPts val="1000"/>
-              </a:spcAft>
-            </a:pPr>
-            <a:r>
-              <a:rPr b="1" sz="1500">
-                <a:solidFill>
-                  <a:srgbClr val="1B365D"/>
-                </a:solidFill>
-              </a:rPr>
-              <a:t>Gaussian Naive Bayes: </a:t>
-            </a:r>
-            <a:r>
-              <a:rPr sz="1500">
-                <a:solidFill>
-                  <a:srgbClr val="333333"/>
-                </a:solidFill>
-              </a:rPr>
-              <a:t>CV ROC-AUC = 0.8773 | Test Acc = 0.7213 | Test Recall = 0.8929 | Test ROC-AUC = 0.8268</a:t>
-            </a:r>
-          </a:p>
-        </p:txBody>
-      </p:sp>
-      <p:pic>
-        <p:nvPicPr>
-          <p:cNvPr id="5" name="Picture 4" descr="baseline_model_comparison.png"/>
-          <p:cNvPicPr>
-            <a:picLocks noChangeAspect="1"/>
-          </p:cNvPicPr>
-          <p:nvPr/>
-        </p:nvPicPr>
-        <p:blipFill>
-          <a:blip r:embed="rId2"/>
-          <a:stretch>
-            <a:fillRect/>
-          </a:stretch>
-        </p:blipFill>
-        <p:spPr>
-          <a:xfrm>
-            <a:off x="6858000" y="1645920"/>
-            <a:ext cx="4754880" cy="2377440"/>
-          </a:xfrm>
-          <a:prstGeom prst="rect">
-            <a:avLst/>
-          </a:prstGeom>
-        </p:spPr>
-      </p:pic>
+              <a:t>7 Baseline Classifiers: </a:t>
+            </a:r>
+            <a:r>
+              <a:rPr sz="1500">
+                <a:solidFill>
+                  <a:srgbClr val="333333"/>
+                </a:solidFill>
+              </a:rPr>
+              <a:t>Logistic Regression, K-Nearest Neighbors, Decision Tree, Random Forest, SVM, Naive Bayes, XGBoost.</a:t>
+            </a:r>
+          </a:p>
+          <a:p>
+            <a:pPr>
+              <a:lnSpc>
+                <a:spcPct val="115000"/>
+              </a:lnSpc>
+              <a:spcAft>
+                <a:spcPts val="1000"/>
+              </a:spcAft>
+            </a:pPr>
+            <a:r>
+              <a:rPr b="1" sz="1500">
+                <a:solidFill>
+                  <a:srgbClr val="1B365D"/>
+                </a:solidFill>
+              </a:rPr>
+              <a:t>Cross-Validation Protocol: </a:t>
+            </a:r>
+            <a:r>
+              <a:rPr sz="1500">
+                <a:solidFill>
+                  <a:srgbClr val="333333"/>
+                </a:solidFill>
+              </a:rPr>
+              <a:t>5-Fold Stratified Cross-Validation (`StratifiedKFold(n_splits=5, shuffle=True, random_state=42)`).</a:t>
+            </a:r>
+          </a:p>
+          <a:p>
+            <a:pPr>
+              <a:lnSpc>
+                <a:spcPct val="115000"/>
+              </a:lnSpc>
+              <a:spcAft>
+                <a:spcPts val="1000"/>
+              </a:spcAft>
+            </a:pPr>
+            <a:r>
+              <a:rPr b="1" sz="1500">
+                <a:solidFill>
+                  <a:srgbClr val="1B365D"/>
+                </a:solidFill>
+              </a:rPr>
+              <a:t>Validation Boundary: </a:t>
+            </a:r>
+            <a:r>
+              <a:rPr sz="1500">
+                <a:solidFill>
+                  <a:srgbClr val="333333"/>
+                </a:solidFill>
+              </a:rPr>
+              <a:t>Cross-validation executed strictly on 242 training rows. Held-out test set (61 rows) kept strictly isolated.</a:t>
+            </a:r>
+          </a:p>
+          <a:p>
+            <a:pPr>
+              <a:lnSpc>
+                <a:spcPct val="115000"/>
+              </a:lnSpc>
+              <a:spcAft>
+                <a:spcPts val="1000"/>
+              </a:spcAft>
+            </a:pPr>
+            <a:r>
+              <a:rPr b="1" sz="1500">
+                <a:solidFill>
+                  <a:srgbClr val="1B365D"/>
+                </a:solidFill>
+              </a:rPr>
+              <a:t>Primary Metric: </a:t>
+            </a:r>
+            <a:r>
+              <a:rPr sz="1500">
+                <a:solidFill>
+                  <a:srgbClr val="333333"/>
+                </a:solidFill>
+              </a:rPr>
+              <a:t>ROC-AUC (Receiver Operating Characteristic - Area Under Curve) selected for threshold-agnostic optimization.</a:t>
+            </a:r>
+          </a:p>
+          <a:p>
+            <a:pPr>
+              <a:lnSpc>
+                <a:spcPct val="115000"/>
+              </a:lnSpc>
+              <a:spcAft>
+                <a:spcPts val="1000"/>
+              </a:spcAft>
+            </a:pPr>
+            <a:r>
+              <a:rPr b="1" sz="1500">
+                <a:solidFill>
+                  <a:srgbClr val="1B365D"/>
+                </a:solidFill>
+              </a:rPr>
+              <a:t>Unified Pipelines: </a:t>
+            </a:r>
+            <a:r>
+              <a:rPr sz="1500">
+                <a:solidFill>
+                  <a:srgbClr val="333333"/>
+                </a:solidFill>
+              </a:rPr>
+              <a:t>All models encapsulated within scikit-learn `Pipeline([('preprocessor', ColumnTransformer), ('classifier', Model)])`.</a:t>
+            </a:r>
+          </a:p>
+        </p:txBody>
+      </p:sp>
     </p:spTree>
   </p:cSld>
   <p:clrMapOvr>

</xml_diff>